<commit_message>
fix a bug in pptx and pdf
</commit_message>
<xml_diff>
--- a/PDFS/C110-08-PREC-ASSOC.pptx
+++ b/PDFS/C110-08-PREC-ASSOC.pptx
@@ -7029,7 +7029,7 @@
               <a:rPr lang="en-US" dirty="0">
                 <a:latin typeface="Courier" pitchFamily="2" charset="0"/>
               </a:rPr>
-              <a:t>TIMES = ’\*’</a:t>
+              <a:t>TIMES = ‘\*’</a:t>
             </a:r>
           </a:p>
           <a:p>
@@ -7047,7 +7047,7 @@
               <a:rPr lang="en-US" dirty="0">
                 <a:latin typeface="Courier" pitchFamily="2" charset="0"/>
               </a:rPr>
-              <a:t>RP    = \)’</a:t>
+              <a:t>RP    = ‘\)’</a:t>
             </a:r>
           </a:p>
           <a:p>
@@ -30978,7 +30978,7 @@
           <p:nvPr>
             <p:extLst>
               <p:ext uri="{D42A27DB-BD31-4B8C-83A1-F6EECF244321}">
-                <p14:modId xmlns:p14="http://schemas.microsoft.com/office/powerpoint/2010/main" val="4157039340"/>
+                <p14:modId xmlns:p14="http://schemas.microsoft.com/office/powerpoint/2010/main" val="3505074647"/>
               </p:ext>
             </p:extLst>
           </p:nvPr>
@@ -31212,6 +31212,11 @@
                   <a:txBody>
                     <a:bodyPr/>
                     <a:lstStyle/>
+                    <a:p>
+                      <a:endParaRPr lang="en-US" sz="1600" dirty="0">
+                        <a:latin typeface="Courier" pitchFamily="2" charset="0"/>
+                      </a:endParaRPr>
+                    </a:p>
                     <a:p>
                       <a:endParaRPr lang="en-US" sz="1600" dirty="0">
                         <a:latin typeface="Courier" pitchFamily="2" charset="0"/>

</xml_diff>

<commit_message>
Minor modifications to C110-08-PREC-ASSOC
</commit_message>
<xml_diff>
--- a/PDFS/C110-08-PREC-ASSOC.pptx
+++ b/PDFS/C110-08-PREC-ASSOC.pptx
@@ -79,8 +79,8 @@
     <p:sldId id="437" r:id="rId70"/>
     <p:sldId id="438" r:id="rId71"/>
     <p:sldId id="439" r:id="rId72"/>
-    <p:sldId id="440" r:id="rId73"/>
-    <p:sldId id="1169" r:id="rId74"/>
+    <p:sldId id="1173" r:id="rId73"/>
+    <p:sldId id="1175" r:id="rId74"/>
     <p:sldId id="1170" r:id="rId75"/>
     <p:sldId id="787" r:id="rId76"/>
   </p:sldIdLst>
@@ -271,7 +271,7 @@
           <a:p>
             <a:fld id="{6F6A6930-6FE4-5249-A389-5C34F8D02512}" type="datetimeFigureOut">
               <a:rPr lang="en-US" smtClean="0"/>
-              <a:t>1/22/2026</a:t>
+              <a:t>1/29/2026</a:t>
             </a:fld>
             <a:endParaRPr lang="en-US"/>
           </a:p>
@@ -853,7 +853,7 @@
           <a:p>
             <a:fld id="{574CE19A-8503-7843-8A88-9F39D8324431}" type="datetimeFigureOut">
               <a:rPr lang="en-US" smtClean="0"/>
-              <a:t>1/22/2026</a:t>
+              <a:t>1/29/2026</a:t>
             </a:fld>
             <a:endParaRPr lang="en-US"/>
           </a:p>
@@ -1051,7 +1051,7 @@
           <a:p>
             <a:fld id="{574CE19A-8503-7843-8A88-9F39D8324431}" type="datetimeFigureOut">
               <a:rPr lang="en-US" smtClean="0"/>
-              <a:t>1/22/2026</a:t>
+              <a:t>1/29/2026</a:t>
             </a:fld>
             <a:endParaRPr lang="en-US"/>
           </a:p>
@@ -1259,7 +1259,7 @@
           <a:p>
             <a:fld id="{574CE19A-8503-7843-8A88-9F39D8324431}" type="datetimeFigureOut">
               <a:rPr lang="en-US" smtClean="0"/>
-              <a:t>1/22/2026</a:t>
+              <a:t>1/29/2026</a:t>
             </a:fld>
             <a:endParaRPr lang="en-US"/>
           </a:p>
@@ -1457,7 +1457,7 @@
           <a:p>
             <a:fld id="{574CE19A-8503-7843-8A88-9F39D8324431}" type="datetimeFigureOut">
               <a:rPr lang="en-US" smtClean="0"/>
-              <a:t>1/22/2026</a:t>
+              <a:t>1/29/2026</a:t>
             </a:fld>
             <a:endParaRPr lang="en-US"/>
           </a:p>
@@ -1732,7 +1732,7 @@
           <a:p>
             <a:fld id="{574CE19A-8503-7843-8A88-9F39D8324431}" type="datetimeFigureOut">
               <a:rPr lang="en-US" smtClean="0"/>
-              <a:t>1/22/2026</a:t>
+              <a:t>1/29/2026</a:t>
             </a:fld>
             <a:endParaRPr lang="en-US"/>
           </a:p>
@@ -1997,7 +1997,7 @@
           <a:p>
             <a:fld id="{574CE19A-8503-7843-8A88-9F39D8324431}" type="datetimeFigureOut">
               <a:rPr lang="en-US" smtClean="0"/>
-              <a:t>1/22/2026</a:t>
+              <a:t>1/29/2026</a:t>
             </a:fld>
             <a:endParaRPr lang="en-US"/>
           </a:p>
@@ -2409,7 +2409,7 @@
           <a:p>
             <a:fld id="{574CE19A-8503-7843-8A88-9F39D8324431}" type="datetimeFigureOut">
               <a:rPr lang="en-US" smtClean="0"/>
-              <a:t>1/22/2026</a:t>
+              <a:t>1/29/2026</a:t>
             </a:fld>
             <a:endParaRPr lang="en-US"/>
           </a:p>
@@ -2550,7 +2550,7 @@
           <a:p>
             <a:fld id="{574CE19A-8503-7843-8A88-9F39D8324431}" type="datetimeFigureOut">
               <a:rPr lang="en-US" smtClean="0"/>
-              <a:t>1/22/2026</a:t>
+              <a:t>1/29/2026</a:t>
             </a:fld>
             <a:endParaRPr lang="en-US"/>
           </a:p>
@@ -2663,7 +2663,7 @@
           <a:p>
             <a:fld id="{574CE19A-8503-7843-8A88-9F39D8324431}" type="datetimeFigureOut">
               <a:rPr lang="en-US" smtClean="0"/>
-              <a:t>1/22/2026</a:t>
+              <a:t>1/29/2026</a:t>
             </a:fld>
             <a:endParaRPr lang="en-US"/>
           </a:p>
@@ -2974,7 +2974,7 @@
           <a:p>
             <a:fld id="{574CE19A-8503-7843-8A88-9F39D8324431}" type="datetimeFigureOut">
               <a:rPr lang="en-US" smtClean="0"/>
-              <a:t>1/22/2026</a:t>
+              <a:t>1/29/2026</a:t>
             </a:fld>
             <a:endParaRPr lang="en-US"/>
           </a:p>
@@ -3262,7 +3262,7 @@
           <a:p>
             <a:fld id="{574CE19A-8503-7843-8A88-9F39D8324431}" type="datetimeFigureOut">
               <a:rPr lang="en-US" smtClean="0"/>
-              <a:t>1/22/2026</a:t>
+              <a:t>1/29/2026</a:t>
             </a:fld>
             <a:endParaRPr lang="en-US"/>
           </a:p>
@@ -3503,7 +3503,7 @@
           <a:p>
             <a:fld id="{574CE19A-8503-7843-8A88-9F39D8324431}" type="datetimeFigureOut">
               <a:rPr lang="en-US" smtClean="0"/>
-              <a:t>1/22/2026</a:t>
+              <a:t>1/29/2026</a:t>
             </a:fld>
             <a:endParaRPr lang="en-US"/>
           </a:p>
@@ -30978,7 +30978,7 @@
           <p:nvPr>
             <p:extLst>
               <p:ext uri="{D42A27DB-BD31-4B8C-83A1-F6EECF244321}">
-                <p14:modId xmlns:p14="http://schemas.microsoft.com/office/powerpoint/2010/main" val="3505074647"/>
+                <p14:modId xmlns:p14="http://schemas.microsoft.com/office/powerpoint/2010/main" val="2204778640"/>
               </p:ext>
             </p:extLst>
           </p:nvPr>
@@ -31068,7 +31068,10 @@
                     <a:bodyPr/>
                     <a:lstStyle/>
                     <a:p>
-                      <a:endParaRPr lang="en-US" dirty="0"/>
+                      <a:r>
+                        <a:rPr lang="en-US" dirty="0"/>
+                        <a:t>PIPE</a:t>
+                      </a:r>
                     </a:p>
                   </a:txBody>
                   <a:tcPr/>
@@ -31078,9 +31081,12 @@
                     <a:bodyPr/>
                     <a:lstStyle/>
                     <a:p>
-                      <a:endParaRPr lang="en-US" sz="1600" dirty="0">
-                        <a:latin typeface="Courier" pitchFamily="2" charset="0"/>
-                      </a:endParaRPr>
+                      <a:r>
+                        <a:rPr lang="en-US" sz="1600" dirty="0">
+                          <a:latin typeface="Courier" pitchFamily="2" charset="0"/>
+                        </a:rPr>
+                        <a:t>choice</a:t>
+                      </a:r>
                     </a:p>
                   </a:txBody>
                   <a:tcPr/>
@@ -31090,6 +31096,20 @@
                     <a:bodyPr/>
                     <a:lstStyle/>
                     <a:p>
+                      <a:r>
+                        <a:rPr lang="en-US" sz="1600" dirty="0">
+                          <a:latin typeface="Courier" pitchFamily="2" charset="0"/>
+                        </a:rPr>
+                        <a:t>choice PIPE choice</a:t>
+                      </a:r>
+                    </a:p>
+                    <a:p>
+                      <a:r>
+                        <a:rPr lang="en-US" sz="1600" dirty="0" err="1">
+                          <a:latin typeface="Courier" pitchFamily="2" charset="0"/>
+                        </a:rPr>
+                        <a:t>concat</a:t>
+                      </a:r>
                       <a:endParaRPr lang="en-US" sz="1600" dirty="0">
                         <a:latin typeface="Courier" pitchFamily="2" charset="0"/>
                       </a:endParaRPr>
@@ -31109,7 +31129,10 @@
                     <a:bodyPr/>
                     <a:lstStyle/>
                     <a:p>
-                      <a:endParaRPr lang="en-US" dirty="0"/>
+                      <a:r>
+                        <a:rPr lang="en-US" dirty="0"/>
+                        <a:t>DOT</a:t>
+                      </a:r>
                     </a:p>
                   </a:txBody>
                   <a:tcPr/>
@@ -31119,6 +31142,12 @@
                     <a:bodyPr/>
                     <a:lstStyle/>
                     <a:p>
+                      <a:r>
+                        <a:rPr lang="en-US" sz="1600" dirty="0" err="1">
+                          <a:latin typeface="Courier" pitchFamily="2" charset="0"/>
+                        </a:rPr>
+                        <a:t>concat</a:t>
+                      </a:r>
                       <a:endParaRPr lang="en-US" sz="1600" dirty="0">
                         <a:latin typeface="Courier" pitchFamily="2" charset="0"/>
                       </a:endParaRPr>
@@ -31131,9 +31160,35 @@
                     <a:bodyPr/>
                     <a:lstStyle/>
                     <a:p>
+                      <a:r>
+                        <a:rPr lang="en-US" sz="1600" dirty="0" err="1">
+                          <a:latin typeface="Courier" pitchFamily="2" charset="0"/>
+                        </a:rPr>
+                        <a:t>Concat</a:t>
+                      </a:r>
+                      <a:r>
+                        <a:rPr lang="en-US" sz="1600" dirty="0">
+                          <a:latin typeface="Courier" pitchFamily="2" charset="0"/>
+                        </a:rPr>
+                        <a:t> DOT </a:t>
+                      </a:r>
+                      <a:r>
+                        <a:rPr lang="en-US" sz="1600" dirty="0" err="1">
+                          <a:latin typeface="Courier" pitchFamily="2" charset="0"/>
+                        </a:rPr>
+                        <a:t>concat</a:t>
+                      </a:r>
                       <a:endParaRPr lang="en-US" sz="1600" dirty="0">
                         <a:latin typeface="Courier" pitchFamily="2" charset="0"/>
                       </a:endParaRPr>
+                    </a:p>
+                    <a:p>
+                      <a:r>
+                        <a:rPr lang="en-US" sz="1600" dirty="0">
+                          <a:latin typeface="Courier" pitchFamily="2" charset="0"/>
+                        </a:rPr>
+                        <a:t>starred</a:t>
+                      </a:r>
                     </a:p>
                   </a:txBody>
                   <a:tcPr/>
@@ -31150,7 +31205,10 @@
                     <a:bodyPr/>
                     <a:lstStyle/>
                     <a:p>
-                      <a:endParaRPr lang="en-US" dirty="0"/>
+                      <a:r>
+                        <a:rPr lang="en-US" dirty="0"/>
+                        <a:t>STAR</a:t>
+                      </a:r>
                     </a:p>
                   </a:txBody>
                   <a:tcPr/>
@@ -31160,9 +31218,12 @@
                     <a:bodyPr/>
                     <a:lstStyle/>
                     <a:p>
-                      <a:endParaRPr lang="en-US" sz="1600" dirty="0">
-                        <a:latin typeface="Courier" pitchFamily="2" charset="0"/>
-                      </a:endParaRPr>
+                      <a:r>
+                        <a:rPr lang="en-US" sz="1600" dirty="0">
+                          <a:latin typeface="Courier" pitchFamily="2" charset="0"/>
+                        </a:rPr>
+                        <a:t>starred</a:t>
+                      </a:r>
                     </a:p>
                   </a:txBody>
                   <a:tcPr/>
@@ -31172,9 +31233,20 @@
                     <a:bodyPr/>
                     <a:lstStyle/>
                     <a:p>
-                      <a:endParaRPr lang="en-US" sz="1600" dirty="0">
-                        <a:latin typeface="Courier" pitchFamily="2" charset="0"/>
-                      </a:endParaRPr>
+                      <a:r>
+                        <a:rPr lang="en-US" sz="1600" dirty="0">
+                          <a:latin typeface="Courier" pitchFamily="2" charset="0"/>
+                        </a:rPr>
+                        <a:t>Starred STAR</a:t>
+                      </a:r>
+                    </a:p>
+                    <a:p>
+                      <a:r>
+                        <a:rPr lang="en-US" sz="1600" dirty="0">
+                          <a:latin typeface="Courier" pitchFamily="2" charset="0"/>
+                        </a:rPr>
+                        <a:t>unit</a:t>
+                      </a:r>
                     </a:p>
                   </a:txBody>
                   <a:tcPr/>
@@ -31201,9 +31273,12 @@
                     <a:bodyPr/>
                     <a:lstStyle/>
                     <a:p>
-                      <a:endParaRPr lang="en-US" sz="1600" dirty="0">
-                        <a:latin typeface="Courier" pitchFamily="2" charset="0"/>
-                      </a:endParaRPr>
+                      <a:r>
+                        <a:rPr lang="en-US" sz="1600" dirty="0">
+                          <a:latin typeface="Courier" pitchFamily="2" charset="0"/>
+                        </a:rPr>
+                        <a:t>unit</a:t>
+                      </a:r>
                     </a:p>
                   </a:txBody>
                   <a:tcPr/>
@@ -31213,14 +31288,20 @@
                     <a:bodyPr/>
                     <a:lstStyle/>
                     <a:p>
-                      <a:endParaRPr lang="en-US" sz="1600" dirty="0">
-                        <a:latin typeface="Courier" pitchFamily="2" charset="0"/>
-                      </a:endParaRPr>
+                      <a:r>
+                        <a:rPr lang="en-US" sz="1600" dirty="0">
+                          <a:latin typeface="Courier" pitchFamily="2" charset="0"/>
+                        </a:rPr>
+                        <a:t>LPAR choice RPAR</a:t>
+                      </a:r>
                     </a:p>
                     <a:p>
-                      <a:endParaRPr lang="en-US" sz="1600" dirty="0">
-                        <a:latin typeface="Courier" pitchFamily="2" charset="0"/>
-                      </a:endParaRPr>
+                      <a:r>
+                        <a:rPr lang="en-US" sz="1600" dirty="0">
+                          <a:latin typeface="Courier" pitchFamily="2" charset="0"/>
+                        </a:rPr>
+                        <a:t>CHAR</a:t>
+                      </a:r>
                     </a:p>
                   </a:txBody>
                   <a:tcPr/>
@@ -42435,7 +42516,7 @@
             </a:pPr>
             <a:r>
               <a:rPr lang="en-US" dirty="0"/>
-              <a:t>Describes the order in which apply the same operator</a:t>
+              <a:t>Describes the order in which we apply the same operator</a:t>
             </a:r>
           </a:p>
           <a:p>
@@ -43051,7 +43132,7 @@
             </a:pPr>
             <a:r>
               <a:rPr lang="en-US" dirty="0"/>
-              <a:t>Describes the order in which apply the same operator</a:t>
+              <a:t>Describes the order in which we apply the same operator</a:t>
             </a:r>
           </a:p>
           <a:p>
@@ -43072,7 +43153,7 @@
           <a:p>
             <a:r>
               <a:rPr lang="en-US" dirty="0"/>
-              <a:t>Integer arithmetic</a:t>
+              <a:t>Integer addition</a:t>
             </a:r>
           </a:p>
           <a:p>
@@ -43373,16 +43454,23 @@
             <p:ph idx="1"/>
           </p:nvPr>
         </p:nvSpPr>
-        <p:spPr/>
-        <p:txBody>
-          <a:bodyPr/>
+        <p:spPr>
+          <a:xfrm>
+            <a:off x="838200" y="1690688"/>
+            <a:ext cx="10515600" cy="4351338"/>
+          </a:xfrm>
+        </p:spPr>
+        <p:txBody>
+          <a:bodyPr>
+            <a:normAutofit fontScale="92500" lnSpcReduction="10000"/>
+          </a:bodyPr>
           <a:lstStyle/>
           <a:p>
             <a:pPr marL="0" indent="0">
               <a:buNone/>
             </a:pPr>
             <a:r>
-              <a:rPr lang="en-US" dirty="0"/>
+              <a:rPr lang="en-US" sz="3600" dirty="0"/>
               <a:t>If an operator is not associative then we define</a:t>
             </a:r>
           </a:p>
@@ -43390,48 +43478,55 @@
             <a:pPr marL="0" indent="0">
               <a:buNone/>
             </a:pPr>
-            <a:endParaRPr lang="en-US" dirty="0"/>
-          </a:p>
-          <a:p>
-            <a:r>
-              <a:rPr lang="en-US" dirty="0"/>
+            <a:endParaRPr lang="en-US" sz="3600" dirty="0"/>
+          </a:p>
+          <a:p>
+            <a:r>
+              <a:rPr lang="en-US" sz="3600" dirty="0"/>
               <a:t>left to right (left-associative)</a:t>
             </a:r>
           </a:p>
           <a:p>
             <a:pPr lvl="1"/>
             <a:r>
-              <a:rPr lang="en-US" dirty="0">
+              <a:rPr lang="en-US" sz="3200" dirty="0">
                 <a:latin typeface="Courier" pitchFamily="2" charset="0"/>
               </a:rPr>
               <a:t>2-3-4 </a:t>
             </a:r>
             <a:r>
-              <a:rPr lang="en-US" dirty="0"/>
+              <a:rPr lang="en-US" sz="3200" dirty="0"/>
               <a:t>is evaluated as ((2-3) - 4)</a:t>
             </a:r>
           </a:p>
           <a:p>
             <a:pPr lvl="1"/>
             <a:r>
-              <a:rPr lang="en-US" dirty="0"/>
+              <a:rPr lang="en-US" sz="3200" dirty="0"/>
               <a:t>What other operators are left-associative</a:t>
             </a:r>
           </a:p>
           <a:p>
-            <a:endParaRPr lang="en-US" dirty="0"/>
-          </a:p>
-          <a:p>
-            <a:r>
-              <a:rPr lang="en-US" dirty="0"/>
+            <a:endParaRPr lang="en-US" sz="3600" dirty="0"/>
+          </a:p>
+          <a:p>
+            <a:r>
+              <a:rPr lang="en-US" sz="3600" dirty="0"/>
               <a:t>right-to-left (right-associative)</a:t>
             </a:r>
           </a:p>
           <a:p>
             <a:pPr lvl="1"/>
             <a:r>
-              <a:rPr lang="en-US" dirty="0"/>
-              <a:t>Assignment, power operator</a:t>
+              <a:rPr lang="en-US" sz="3200" dirty="0"/>
+              <a:t>Assignment, </a:t>
+            </a:r>
+          </a:p>
+          <a:p>
+            <a:pPr lvl="1"/>
+            <a:r>
+              <a:rPr lang="en-US" sz="3200" dirty="0"/>
+              <a:t>power operator</a:t>
             </a:r>
           </a:p>
         </p:txBody>
@@ -43512,28 +43607,30 @@
         </p:nvSpPr>
         <p:spPr/>
         <p:txBody>
-          <a:bodyPr/>
-          <a:lstStyle/>
-          <a:p>
-            <a:r>
-              <a:rPr lang="en-US" dirty="0"/>
+          <a:bodyPr>
+            <a:normAutofit/>
+          </a:bodyPr>
+          <a:lstStyle/>
+          <a:p>
+            <a:r>
+              <a:rPr lang="en-US" sz="3600" dirty="0"/>
               <a:t>Like precedence, some tools (e.g. YACC) allow associativity specification through keywords:</a:t>
             </a:r>
           </a:p>
           <a:p>
             <a:pPr lvl="1"/>
             <a:r>
-              <a:rPr lang="en-US" dirty="0"/>
+              <a:rPr lang="en-US" sz="3200" dirty="0"/>
               <a:t>“+”: left, “^”: right</a:t>
             </a:r>
           </a:p>
           <a:p>
             <a:pPr lvl="1"/>
-            <a:endParaRPr lang="en-US" dirty="0"/>
-          </a:p>
-          <a:p>
-            <a:r>
-              <a:rPr lang="en-US" dirty="0"/>
+            <a:endParaRPr lang="en-US" sz="3200" dirty="0"/>
+          </a:p>
+          <a:p>
+            <a:r>
+              <a:rPr lang="en-US" sz="3600" dirty="0"/>
               <a:t>Like precedence, we can also encode it into the production rules</a:t>
             </a:r>
           </a:p>
@@ -45488,6 +45585,41 @@
           </a:graphicData>
         </a:graphic>
       </p:graphicFrame>
+      <p:sp>
+        <p:nvSpPr>
+          <p:cNvPr id="4" name="TextBox 3">
+            <a:extLst>
+              <a:ext uri="{FF2B5EF4-FFF2-40B4-BE49-F238E27FC236}">
+                <a16:creationId xmlns:a16="http://schemas.microsoft.com/office/drawing/2014/main" id="{A4747FED-F887-1B41-D848-CBA57C7CCCBE}"/>
+              </a:ext>
+            </a:extLst>
+          </p:cNvPr>
+          <p:cNvSpPr txBox="1"/>
+          <p:nvPr/>
+        </p:nvSpPr>
+        <p:spPr>
+          <a:xfrm>
+            <a:off x="445825" y="5141626"/>
+            <a:ext cx="5650176" cy="707886"/>
+          </a:xfrm>
+          <a:prstGeom prst="rect">
+            <a:avLst/>
+          </a:prstGeom>
+          <a:noFill/>
+        </p:spPr>
+        <p:txBody>
+          <a:bodyPr wrap="square" rtlCol="0">
+            <a:spAutoFit/>
+          </a:bodyPr>
+          <a:lstStyle/>
+          <a:p>
+            <a:r>
+              <a:rPr lang="en-US" sz="2000" dirty="0"/>
+              <a:t>Note that with recursion on the left derivations can only happen from left to right.</a:t>
+            </a:r>
+          </a:p>
+        </p:txBody>
+      </p:sp>
     </p:spTree>
     <p:extLst>
       <p:ext uri="{BB962C8B-B14F-4D97-AF65-F5344CB8AC3E}">
@@ -50207,7 +50339,13 @@
   <p:cSld>
     <p:spTree>
       <p:nvGrpSpPr>
-        <p:cNvPr id="1" name=""/>
+        <p:cNvPr id="1" name="">
+          <a:extLst>
+            <a:ext uri="{FF2B5EF4-FFF2-40B4-BE49-F238E27FC236}">
+              <a16:creationId xmlns:a16="http://schemas.microsoft.com/office/drawing/2014/main" id="{EABD7F5C-D52B-FA56-39C5-6D3B0923D06E}"/>
+            </a:ext>
+          </a:extLst>
+        </p:cNvPr>
         <p:cNvGrpSpPr/>
         <p:nvPr/>
       </p:nvGrpSpPr>
@@ -50224,7 +50362,7 @@
           <p:cNvPr id="2" name="Title 1">
             <a:extLst>
               <a:ext uri="{FF2B5EF4-FFF2-40B4-BE49-F238E27FC236}">
-                <a16:creationId xmlns:a16="http://schemas.microsoft.com/office/drawing/2014/main" id="{F0127807-B712-4841-B38C-AA3AB7614A26}"/>
+                <a16:creationId xmlns:a16="http://schemas.microsoft.com/office/drawing/2014/main" id="{4C8683B7-4FDD-067A-8B10-849538D0FDA7}"/>
               </a:ext>
             </a:extLst>
           </p:cNvPr>
@@ -50235,7 +50373,12 @@
             <p:ph type="title"/>
           </p:nvPr>
         </p:nvSpPr>
-        <p:spPr/>
+        <p:spPr>
+          <a:xfrm>
+            <a:off x="838200" y="281870"/>
+            <a:ext cx="10515600" cy="1325563"/>
+          </a:xfrm>
+        </p:spPr>
         <p:txBody>
           <a:bodyPr/>
           <a:lstStyle/>
@@ -50252,7 +50395,7 @@
           <p:cNvPr id="4" name="Table 5">
             <a:extLst>
               <a:ext uri="{FF2B5EF4-FFF2-40B4-BE49-F238E27FC236}">
-                <a16:creationId xmlns:a16="http://schemas.microsoft.com/office/drawing/2014/main" id="{555BFBB7-BD21-BD4E-A7C1-22A55B94FDF7}"/>
+                <a16:creationId xmlns:a16="http://schemas.microsoft.com/office/drawing/2014/main" id="{FEF283D2-140C-125B-5885-9DFA9AFBAE1F}"/>
               </a:ext>
             </a:extLst>
           </p:cNvPr>
@@ -50262,14 +50405,14 @@
           <p:nvPr>
             <p:extLst>
               <p:ext uri="{D42A27DB-BD31-4B8C-83A1-F6EECF244321}">
-                <p14:modId xmlns:p14="http://schemas.microsoft.com/office/powerpoint/2010/main" val="3429727317"/>
+                <p14:modId xmlns:p14="http://schemas.microsoft.com/office/powerpoint/2010/main" val="2843537453"/>
               </p:ext>
             </p:extLst>
           </p:nvPr>
         </p:nvGraphicFramePr>
         <p:xfrm>
-          <a:off x="1012544" y="2867685"/>
-          <a:ext cx="4944119" cy="2869230"/>
+          <a:off x="661060" y="1416197"/>
+          <a:ext cx="4970245" cy="2869230"/>
         </p:xfrm>
         <a:graphic>
           <a:graphicData uri="http://schemas.openxmlformats.org/drawingml/2006/table">
@@ -50278,21 +50421,21 @@
                 <a:tableStyleId>{073A0DAA-6AF3-43AB-8588-CEC1D06C72B9}</a:tableStyleId>
               </a:tblPr>
               <a:tblGrid>
-                <a:gridCol w="1620381">
+                <a:gridCol w="1628944">
                   <a:extLst>
                     <a:ext uri="{9D8B030D-6E8A-4147-A177-3AD203B41FA5}">
                       <a16:colId xmlns:a16="http://schemas.microsoft.com/office/drawing/2014/main" val="1179443482"/>
                     </a:ext>
                   </a:extLst>
                 </a:gridCol>
-                <a:gridCol w="1045206">
+                <a:gridCol w="1050729">
                   <a:extLst>
                     <a:ext uri="{9D8B030D-6E8A-4147-A177-3AD203B41FA5}">
                       <a16:colId xmlns:a16="http://schemas.microsoft.com/office/drawing/2014/main" val="1466143606"/>
                     </a:ext>
                   </a:extLst>
                 </a:gridCol>
-                <a:gridCol w="2278532">
+                <a:gridCol w="2290572">
                   <a:extLst>
                     <a:ext uri="{9D8B030D-6E8A-4147-A177-3AD203B41FA5}">
                       <a16:colId xmlns:a16="http://schemas.microsoft.com/office/drawing/2014/main" val="2892710420"/>
@@ -50516,10 +50659,10 @@
       </p:graphicFrame>
       <p:sp>
         <p:nvSpPr>
-          <p:cNvPr id="3" name="Rectangle 2">
-            <a:extLst>
-              <a:ext uri="{FF2B5EF4-FFF2-40B4-BE49-F238E27FC236}">
-                <a16:creationId xmlns:a16="http://schemas.microsoft.com/office/drawing/2014/main" id="{C642D2B4-D83F-6A9E-59D0-C5E792C2DA66}"/>
+          <p:cNvPr id="7" name="Rectangle 6">
+            <a:extLst>
+              <a:ext uri="{FF2B5EF4-FFF2-40B4-BE49-F238E27FC236}">
+                <a16:creationId xmlns:a16="http://schemas.microsoft.com/office/drawing/2014/main" id="{661E5546-89FE-3707-DDD4-4DCFE8F71AA2}"/>
               </a:ext>
             </a:extLst>
           </p:cNvPr>
@@ -50528,7 +50671,7 @@
         </p:nvSpPr>
         <p:spPr>
           <a:xfrm>
-            <a:off x="6337258" y="3924457"/>
+            <a:off x="6337258" y="2770214"/>
             <a:ext cx="3025628" cy="2862322"/>
           </a:xfrm>
           <a:prstGeom prst="rect">
@@ -50631,10 +50774,10 @@
       </p:sp>
       <p:sp>
         <p:nvSpPr>
-          <p:cNvPr id="5" name="TextBox 4">
-            <a:extLst>
-              <a:ext uri="{FF2B5EF4-FFF2-40B4-BE49-F238E27FC236}">
-                <a16:creationId xmlns:a16="http://schemas.microsoft.com/office/drawing/2014/main" id="{84847AEA-6DAC-42F2-A657-FA3919D258DF}"/>
+          <p:cNvPr id="8" name="TextBox 7">
+            <a:extLst>
+              <a:ext uri="{FF2B5EF4-FFF2-40B4-BE49-F238E27FC236}">
+                <a16:creationId xmlns:a16="http://schemas.microsoft.com/office/drawing/2014/main" id="{46DD50F5-B700-DFD9-EB52-D1FB640799F3}"/>
               </a:ext>
             </a:extLst>
           </p:cNvPr>
@@ -50643,8 +50786,8 @@
         </p:nvSpPr>
         <p:spPr>
           <a:xfrm>
-            <a:off x="6436723" y="2098766"/>
-            <a:ext cx="4252126" cy="369332"/>
+            <a:off x="6337258" y="1914100"/>
+            <a:ext cx="4552465" cy="400110"/>
           </a:xfrm>
           <a:prstGeom prst="rect">
             <a:avLst/>
@@ -50658,21 +50801,33 @@
           <a:lstStyle/>
           <a:p>
             <a:r>
-              <a:rPr lang="en-US" i="1" dirty="0"/>
+              <a:rPr lang="en-US" sz="2000" i="1" dirty="0"/>
               <a:t>Let’s do operators </a:t>
             </a:r>
             <a:r>
-              <a:rPr lang="en-US" i="1" dirty="0">
+              <a:rPr lang="en-US" sz="2000" i="1" dirty="0">
                 <a:latin typeface="Courier" pitchFamily="2" charset="0"/>
               </a:rPr>
-              <a:t>[+,*,-,/,^]</a:t>
-            </a:r>
-            <a:r>
-              <a:rPr lang="en-US" i="1" dirty="0"/>
+              <a:t>[</a:t>
+            </a:r>
+            <a:r>
+              <a:rPr lang="en-US" sz="2000" b="1" i="1" dirty="0">
+                <a:latin typeface="Courier" pitchFamily="2" charset="0"/>
+              </a:rPr>
+              <a:t>+,*,-,/,^</a:t>
+            </a:r>
+            <a:r>
+              <a:rPr lang="en-US" sz="2000" i="1" dirty="0">
+                <a:latin typeface="Courier" pitchFamily="2" charset="0"/>
+              </a:rPr>
+              <a:t>]</a:t>
+            </a:r>
+            <a:r>
+              <a:rPr lang="en-US" sz="2000" i="1" dirty="0"/>
               <a:t> and</a:t>
             </a:r>
             <a:r>
-              <a:rPr lang="en-US" i="1" dirty="0">
+              <a:rPr lang="en-US" sz="2000" b="1" i="1" dirty="0">
                 <a:latin typeface="Courier" pitchFamily="2" charset="0"/>
               </a:rPr>
               <a:t>()</a:t>
@@ -50682,10 +50837,10 @@
       </p:sp>
       <p:sp>
         <p:nvSpPr>
-          <p:cNvPr id="6" name="TextBox 5">
-            <a:extLst>
-              <a:ext uri="{FF2B5EF4-FFF2-40B4-BE49-F238E27FC236}">
-                <a16:creationId xmlns:a16="http://schemas.microsoft.com/office/drawing/2014/main" id="{F5EA8597-2EE3-BA73-CB85-28E3594C55C9}"/>
+          <p:cNvPr id="3" name="TextBox 2">
+            <a:extLst>
+              <a:ext uri="{FF2B5EF4-FFF2-40B4-BE49-F238E27FC236}">
+                <a16:creationId xmlns:a16="http://schemas.microsoft.com/office/drawing/2014/main" id="{F0115341-5B23-5605-3B7D-08302F9FC72F}"/>
               </a:ext>
             </a:extLst>
           </p:cNvPr>
@@ -50694,8 +50849,8 @@
         </p:nvSpPr>
         <p:spPr>
           <a:xfrm>
-            <a:off x="9710989" y="3947317"/>
-            <a:ext cx="2285067" cy="1754326"/>
+            <a:off x="617866" y="5185169"/>
+            <a:ext cx="5056632" cy="1200329"/>
           </a:xfrm>
           <a:prstGeom prst="rect">
             <a:avLst/>
@@ -50710,13 +50865,65 @@
           <a:p>
             <a:r>
               <a:rPr lang="en-US" b="1" dirty="0"/>
-              <a:t>Possible names for</a:t>
-            </a:r>
-          </a:p>
-          <a:p>
-            <a:r>
+              <a:t>Note the recursion from pow makes raising to a </a:t>
+            </a:r>
+            <a:br>
               <a:rPr lang="en-US" b="1" dirty="0"/>
-              <a:t>  NT (non-terminals):</a:t>
+            </a:br>
+            <a:r>
+              <a:rPr lang="en-US" b="1" dirty="0"/>
+              <a:t>power right to left associative, </a:t>
+            </a:r>
+          </a:p>
+          <a:p>
+            <a:r>
+              <a:rPr lang="en-US" b="1" dirty="0"/>
+              <a:t>As opposed to PLUS, MINUS, TIMES DIV</a:t>
+            </a:r>
+          </a:p>
+          <a:p>
+            <a:r>
+              <a:rPr lang="en-US" b="1" dirty="0"/>
+              <a:t>Which are left-to-right associative</a:t>
+            </a:r>
+            <a:r>
+              <a:rPr lang="en-US" dirty="0"/>
+              <a:t>.</a:t>
+            </a:r>
+          </a:p>
+        </p:txBody>
+      </p:sp>
+      <p:sp>
+        <p:nvSpPr>
+          <p:cNvPr id="5" name="TextBox 4">
+            <a:extLst>
+              <a:ext uri="{FF2B5EF4-FFF2-40B4-BE49-F238E27FC236}">
+                <a16:creationId xmlns:a16="http://schemas.microsoft.com/office/drawing/2014/main" id="{C133C9A2-0D5B-2857-A0AB-3A0A9D716ED1}"/>
+              </a:ext>
+            </a:extLst>
+          </p:cNvPr>
+          <p:cNvSpPr txBox="1"/>
+          <p:nvPr/>
+        </p:nvSpPr>
+        <p:spPr>
+          <a:xfrm>
+            <a:off x="9773587" y="2770214"/>
+            <a:ext cx="1918741" cy="1754326"/>
+          </a:xfrm>
+          <a:prstGeom prst="rect">
+            <a:avLst/>
+          </a:prstGeom>
+          <a:noFill/>
+        </p:spPr>
+        <p:txBody>
+          <a:bodyPr wrap="square" rtlCol="0">
+            <a:spAutoFit/>
+          </a:bodyPr>
+          <a:lstStyle/>
+          <a:p>
+            <a:r>
+              <a:rPr lang="en-US" dirty="0"/>
+              <a:t>Assume Non-Term names:</a:t>
             </a:r>
           </a:p>
           <a:p>
@@ -50741,6 +50948,41 @@
             <a:r>
               <a:rPr lang="en-US" dirty="0"/>
               <a:t>    factor</a:t>
+            </a:r>
+          </a:p>
+        </p:txBody>
+      </p:sp>
+      <p:sp>
+        <p:nvSpPr>
+          <p:cNvPr id="6" name="TextBox 5">
+            <a:extLst>
+              <a:ext uri="{FF2B5EF4-FFF2-40B4-BE49-F238E27FC236}">
+                <a16:creationId xmlns:a16="http://schemas.microsoft.com/office/drawing/2014/main" id="{53AF510C-D98D-A89A-2749-73FE6071B5F1}"/>
+              </a:ext>
+            </a:extLst>
+          </p:cNvPr>
+          <p:cNvSpPr txBox="1"/>
+          <p:nvPr/>
+        </p:nvSpPr>
+        <p:spPr>
+          <a:xfrm>
+            <a:off x="5704352" y="5687321"/>
+            <a:ext cx="5649448" cy="461665"/>
+          </a:xfrm>
+          <a:prstGeom prst="rect">
+            <a:avLst/>
+          </a:prstGeom>
+          <a:noFill/>
+        </p:spPr>
+        <p:txBody>
+          <a:bodyPr wrap="square" rtlCol="0">
+            <a:spAutoFit/>
+          </a:bodyPr>
+          <a:lstStyle/>
+          <a:p>
+            <a:r>
+              <a:rPr lang="en-US" sz="2400" dirty="0"/>
+              <a:t>First consider precedence, then associativity</a:t>
             </a:r>
           </a:p>
         </p:txBody>
@@ -50748,7 +50990,7 @@
     </p:spTree>
     <p:extLst>
       <p:ext uri="{BB962C8B-B14F-4D97-AF65-F5344CB8AC3E}">
-        <p14:creationId xmlns:p14="http://schemas.microsoft.com/office/powerpoint/2010/main" val="2667554543"/>
+        <p14:creationId xmlns:p14="http://schemas.microsoft.com/office/powerpoint/2010/main" val="1956742328"/>
       </p:ext>
     </p:extLst>
   </p:cSld>
@@ -50763,7 +51005,13 @@
   <p:cSld>
     <p:spTree>
       <p:nvGrpSpPr>
-        <p:cNvPr id="1" name=""/>
+        <p:cNvPr id="1" name="">
+          <a:extLst>
+            <a:ext uri="{FF2B5EF4-FFF2-40B4-BE49-F238E27FC236}">
+              <a16:creationId xmlns:a16="http://schemas.microsoft.com/office/drawing/2014/main" id="{3E4C9BB1-A4F8-C449-73D4-94B63AFB3AFE}"/>
+            </a:ext>
+          </a:extLst>
+        </p:cNvPr>
         <p:cNvGrpSpPr/>
         <p:nvPr/>
       </p:nvGrpSpPr>
@@ -50780,7 +51028,7 @@
           <p:cNvPr id="2" name="Title 1">
             <a:extLst>
               <a:ext uri="{FF2B5EF4-FFF2-40B4-BE49-F238E27FC236}">
-                <a16:creationId xmlns:a16="http://schemas.microsoft.com/office/drawing/2014/main" id="{F0127807-B712-4841-B38C-AA3AB7614A26}"/>
+                <a16:creationId xmlns:a16="http://schemas.microsoft.com/office/drawing/2014/main" id="{D624F14F-49E3-EA83-1193-B87E75A4D029}"/>
               </a:ext>
             </a:extLst>
           </p:cNvPr>
@@ -50791,7 +51039,12 @@
             <p:ph type="title"/>
           </p:nvPr>
         </p:nvSpPr>
-        <p:spPr/>
+        <p:spPr>
+          <a:xfrm>
+            <a:off x="838200" y="281870"/>
+            <a:ext cx="10515600" cy="1325563"/>
+          </a:xfrm>
+        </p:spPr>
         <p:txBody>
           <a:bodyPr/>
           <a:lstStyle/>
@@ -50808,23 +51061,17 @@
           <p:cNvPr id="4" name="Table 5">
             <a:extLst>
               <a:ext uri="{FF2B5EF4-FFF2-40B4-BE49-F238E27FC236}">
-                <a16:creationId xmlns:a16="http://schemas.microsoft.com/office/drawing/2014/main" id="{555BFBB7-BD21-BD4E-A7C1-22A55B94FDF7}"/>
+                <a16:creationId xmlns:a16="http://schemas.microsoft.com/office/drawing/2014/main" id="{80422B64-58E0-A985-2E73-E42FF0116549}"/>
               </a:ext>
             </a:extLst>
           </p:cNvPr>
           <p:cNvGraphicFramePr>
             <a:graphicFrameLocks noGrp="1"/>
           </p:cNvGraphicFramePr>
-          <p:nvPr>
-            <p:extLst>
-              <p:ext uri="{D42A27DB-BD31-4B8C-83A1-F6EECF244321}">
-                <p14:modId xmlns:p14="http://schemas.microsoft.com/office/powerpoint/2010/main" val="1441029008"/>
-              </p:ext>
-            </p:extLst>
-          </p:nvPr>
+          <p:nvPr/>
         </p:nvGraphicFramePr>
         <p:xfrm>
-          <a:off x="1125755" y="1930864"/>
+          <a:off x="661060" y="1672831"/>
           <a:ext cx="4970245" cy="3184578"/>
         </p:xfrm>
         <a:graphic>
@@ -51168,7 +51415,7 @@
           <p:cNvPr id="7" name="Rectangle 6">
             <a:extLst>
               <a:ext uri="{FF2B5EF4-FFF2-40B4-BE49-F238E27FC236}">
-                <a16:creationId xmlns:a16="http://schemas.microsoft.com/office/drawing/2014/main" id="{B852ADBF-91C9-3944-A83E-C428EFED6E0A}"/>
+                <a16:creationId xmlns:a16="http://schemas.microsoft.com/office/drawing/2014/main" id="{870E3264-23C0-AC64-6E7C-6FC6B1117084}"/>
               </a:ext>
             </a:extLst>
           </p:cNvPr>
@@ -51177,7 +51424,7 @@
         </p:nvSpPr>
         <p:spPr>
           <a:xfrm>
-            <a:off x="6337258" y="3924457"/>
+            <a:off x="6337258" y="2770214"/>
             <a:ext cx="3025628" cy="2862322"/>
           </a:xfrm>
           <a:prstGeom prst="rect">
@@ -51283,7 +51530,7 @@
           <p:cNvPr id="8" name="TextBox 7">
             <a:extLst>
               <a:ext uri="{FF2B5EF4-FFF2-40B4-BE49-F238E27FC236}">
-                <a16:creationId xmlns:a16="http://schemas.microsoft.com/office/drawing/2014/main" id="{5C253672-0548-D941-9533-503EF3DAD92F}"/>
+                <a16:creationId xmlns:a16="http://schemas.microsoft.com/office/drawing/2014/main" id="{521A8646-2CF9-10BB-CF30-ECF5D9182338}"/>
               </a:ext>
             </a:extLst>
           </p:cNvPr>
@@ -51292,8 +51539,8 @@
         </p:nvSpPr>
         <p:spPr>
           <a:xfrm>
-            <a:off x="6436723" y="2098766"/>
-            <a:ext cx="4252126" cy="369332"/>
+            <a:off x="6337258" y="1914100"/>
+            <a:ext cx="4552465" cy="400110"/>
           </a:xfrm>
           <a:prstGeom prst="rect">
             <a:avLst/>
@@ -51307,21 +51554,21 @@
           <a:lstStyle/>
           <a:p>
             <a:r>
-              <a:rPr lang="en-US" i="1" dirty="0"/>
+              <a:rPr lang="en-US" sz="2000" i="1" dirty="0"/>
               <a:t>Let’s do operators </a:t>
             </a:r>
             <a:r>
-              <a:rPr lang="en-US" i="1" dirty="0">
+              <a:rPr lang="en-US" sz="2000" i="1" dirty="0">
                 <a:latin typeface="Courier" pitchFamily="2" charset="0"/>
               </a:rPr>
               <a:t>[+,*,-,/,^]</a:t>
             </a:r>
             <a:r>
-              <a:rPr lang="en-US" i="1" dirty="0"/>
+              <a:rPr lang="en-US" sz="2000" i="1" dirty="0"/>
               <a:t> and</a:t>
             </a:r>
             <a:r>
-              <a:rPr lang="en-US" i="1" dirty="0">
+              <a:rPr lang="en-US" sz="2000" i="1" dirty="0">
                 <a:latin typeface="Courier" pitchFamily="2" charset="0"/>
               </a:rPr>
               <a:t>()</a:t>
@@ -51334,7 +51581,7 @@
           <p:cNvPr id="3" name="TextBox 2">
             <a:extLst>
               <a:ext uri="{FF2B5EF4-FFF2-40B4-BE49-F238E27FC236}">
-                <a16:creationId xmlns:a16="http://schemas.microsoft.com/office/drawing/2014/main" id="{51736568-A251-64D0-CE75-9ED7DFB5F711}"/>
+                <a16:creationId xmlns:a16="http://schemas.microsoft.com/office/drawing/2014/main" id="{35AC2796-78A8-5037-0E10-C293E002EBEC}"/>
               </a:ext>
             </a:extLst>
           </p:cNvPr>
@@ -51343,7 +51590,7 @@
         </p:nvSpPr>
         <p:spPr>
           <a:xfrm>
-            <a:off x="1082561" y="5355618"/>
+            <a:off x="617866" y="5185169"/>
             <a:ext cx="5056632" cy="1200329"/>
           </a:xfrm>
           <a:prstGeom prst="rect">
@@ -51387,10 +51634,69 @@
           </a:p>
         </p:txBody>
       </p:sp>
+      <p:sp>
+        <p:nvSpPr>
+          <p:cNvPr id="5" name="TextBox 4">
+            <a:extLst>
+              <a:ext uri="{FF2B5EF4-FFF2-40B4-BE49-F238E27FC236}">
+                <a16:creationId xmlns:a16="http://schemas.microsoft.com/office/drawing/2014/main" id="{08708AFC-0B36-5352-6D0D-FF9C5D74A554}"/>
+              </a:ext>
+            </a:extLst>
+          </p:cNvPr>
+          <p:cNvSpPr txBox="1"/>
+          <p:nvPr/>
+        </p:nvSpPr>
+        <p:spPr>
+          <a:xfrm>
+            <a:off x="9773587" y="2770214"/>
+            <a:ext cx="1918741" cy="1754326"/>
+          </a:xfrm>
+          <a:prstGeom prst="rect">
+            <a:avLst/>
+          </a:prstGeom>
+          <a:noFill/>
+        </p:spPr>
+        <p:txBody>
+          <a:bodyPr wrap="square" rtlCol="0">
+            <a:spAutoFit/>
+          </a:bodyPr>
+          <a:lstStyle/>
+          <a:p>
+            <a:r>
+              <a:rPr lang="en-US" dirty="0"/>
+              <a:t>Assume Non-Term names:</a:t>
+            </a:r>
+          </a:p>
+          <a:p>
+            <a:r>
+              <a:rPr lang="en-US" dirty="0"/>
+              <a:t>    expr</a:t>
+            </a:r>
+          </a:p>
+          <a:p>
+            <a:r>
+              <a:rPr lang="en-US" dirty="0"/>
+              <a:t>    term</a:t>
+            </a:r>
+          </a:p>
+          <a:p>
+            <a:r>
+              <a:rPr lang="en-US" dirty="0"/>
+              <a:t>    pow</a:t>
+            </a:r>
+          </a:p>
+          <a:p>
+            <a:r>
+              <a:rPr lang="en-US" dirty="0"/>
+              <a:t>    factor</a:t>
+            </a:r>
+          </a:p>
+        </p:txBody>
+      </p:sp>
     </p:spTree>
     <p:extLst>
       <p:ext uri="{BB962C8B-B14F-4D97-AF65-F5344CB8AC3E}">
-        <p14:creationId xmlns:p14="http://schemas.microsoft.com/office/powerpoint/2010/main" val="3111683782"/>
+        <p14:creationId xmlns:p14="http://schemas.microsoft.com/office/powerpoint/2010/main" val="1498400459"/>
       </p:ext>
     </p:extLst>
   </p:cSld>
@@ -51555,7 +51861,7 @@
           <a:p>
             <a:r>
               <a:rPr lang="en-US" dirty="0"/>
-              <a:t>Next time: algorithms for syntactic analysis</a:t>
+              <a:t>Next topic: algorithms for syntactic analysis</a:t>
             </a:r>
           </a:p>
         </p:txBody>

</xml_diff>